<commit_message>
feat: add dish and menu management controller, routes, and frontend page
</commit_message>
<xml_diff>
--- a/BaoCao_TongQuan_DoAn_BackEnd_RoyalBistro.pptx
+++ b/BaoCao_TongQuan_DoAn_BackEnd_RoyalBistro.pptx
@@ -142,7 +142,7 @@
   <pc:docChgLst>
     <pc:chgData name="Hưng Nguyễn" userId="62088adbe5b10a38" providerId="LiveId" clId="{0038B2EA-E61B-494E-8805-E1A7D9E185B2}"/>
     <pc:docChg chg="custSel delSld modSld">
-      <pc:chgData name="Hưng Nguyễn" userId="62088adbe5b10a38" providerId="LiveId" clId="{0038B2EA-E61B-494E-8805-E1A7D9E185B2}" dt="2026-10-20T01:50:20.361" v="211" actId="1076"/>
+      <pc:chgData name="Hưng Nguyễn" userId="62088adbe5b10a38" providerId="LiveId" clId="{0038B2EA-E61B-494E-8805-E1A7D9E185B2}" dt="2026-10-20T02:31:04.689" v="223" actId="403"/>
       <pc:docMkLst>
         <pc:docMk/>
       </pc:docMkLst>
@@ -178,7 +178,7 @@
         </pc:spChg>
       </pc:sldChg>
       <pc:sldChg chg="modSp mod">
-        <pc:chgData name="Hưng Nguyễn" userId="62088adbe5b10a38" providerId="LiveId" clId="{0038B2EA-E61B-494E-8805-E1A7D9E185B2}" dt="2026-10-20T01:18:27.375" v="21" actId="403"/>
+        <pc:chgData name="Hưng Nguyễn" userId="62088adbe5b10a38" providerId="LiveId" clId="{0038B2EA-E61B-494E-8805-E1A7D9E185B2}" dt="2026-10-20T02:31:04.689" v="223" actId="403"/>
         <pc:sldMkLst>
           <pc:docMk/>
           <pc:sldMk cId="0" sldId="257"/>
@@ -197,6 +197,38 @@
             <pc:docMk/>
             <pc:sldMk cId="0" sldId="257"/>
             <ac:spMk id="9" creationId="{00000000-0000-0000-0000-000000000000}"/>
+          </ac:spMkLst>
+        </pc:spChg>
+        <pc:spChg chg="mod">
+          <ac:chgData name="Hưng Nguyễn" userId="62088adbe5b10a38" providerId="LiveId" clId="{0038B2EA-E61B-494E-8805-E1A7D9E185B2}" dt="2026-10-20T02:30:50.029" v="214" actId="403"/>
+          <ac:spMkLst>
+            <pc:docMk/>
+            <pc:sldMk cId="0" sldId="257"/>
+            <ac:spMk id="10" creationId="{00000000-0000-0000-0000-000000000000}"/>
+          </ac:spMkLst>
+        </pc:spChg>
+        <pc:spChg chg="mod">
+          <ac:chgData name="Hưng Nguyễn" userId="62088adbe5b10a38" providerId="LiveId" clId="{0038B2EA-E61B-494E-8805-E1A7D9E185B2}" dt="2026-10-20T02:30:54.976" v="217" actId="403"/>
+          <ac:spMkLst>
+            <pc:docMk/>
+            <pc:sldMk cId="0" sldId="257"/>
+            <ac:spMk id="11" creationId="{00000000-0000-0000-0000-000000000000}"/>
+          </ac:spMkLst>
+        </pc:spChg>
+        <pc:spChg chg="mod">
+          <ac:chgData name="Hưng Nguyễn" userId="62088adbe5b10a38" providerId="LiveId" clId="{0038B2EA-E61B-494E-8805-E1A7D9E185B2}" dt="2026-10-20T02:30:58.180" v="220" actId="403"/>
+          <ac:spMkLst>
+            <pc:docMk/>
+            <pc:sldMk cId="0" sldId="257"/>
+            <ac:spMk id="12" creationId="{00000000-0000-0000-0000-000000000000}"/>
+          </ac:spMkLst>
+        </pc:spChg>
+        <pc:spChg chg="mod">
+          <ac:chgData name="Hưng Nguyễn" userId="62088adbe5b10a38" providerId="LiveId" clId="{0038B2EA-E61B-494E-8805-E1A7D9E185B2}" dt="2026-10-20T02:31:04.689" v="223" actId="403"/>
+          <ac:spMkLst>
+            <pc:docMk/>
+            <pc:sldMk cId="0" sldId="257"/>
+            <ac:spMk id="13" creationId="{00000000-0000-0000-0000-000000000000}"/>
           </ac:spMkLst>
         </pc:spChg>
       </pc:sldChg>
@@ -6876,6 +6908,7 @@
               </a:defRPr>
             </a:pPr>
             <a:r>
+              <a:rPr sz="1200"/>
               <a:t>👑 Quản trị viên (Admin)</a:t>
             </a:r>
           </a:p>
@@ -6892,6 +6925,7 @@
               </a:defRPr>
             </a:pPr>
             <a:r>
+              <a:rPr sz="1050"/>
               <a:t>Toàn quyền thực đơn, kho, nhân sự, báo cáo</a:t>
             </a:r>
           </a:p>
@@ -6947,6 +6981,7 @@
               </a:defRPr>
             </a:pPr>
             <a:r>
+              <a:rPr sz="1200"/>
               <a:t>💳 Thu ngân / Phục vụ</a:t>
             </a:r>
           </a:p>
@@ -6963,6 +6998,7 @@
               </a:defRPr>
             </a:pPr>
             <a:r>
+              <a:rPr sz="1050"/>
               <a:t>Mở bàn, tiếp nhận order POS, thanh toán</a:t>
             </a:r>
           </a:p>
@@ -7018,6 +7054,7 @@
               </a:defRPr>
             </a:pPr>
             <a:r>
+              <a:rPr sz="1200"/>
               <a:t>🍳 Đầu bếp (Kitchen/Chef)</a:t>
             </a:r>
           </a:p>
@@ -7034,6 +7071,7 @@
               </a:defRPr>
             </a:pPr>
             <a:r>
+              <a:rPr sz="1050"/>
               <a:t>Xem hàng đợi KDS, nấu món, kích hoạt trừ kho</a:t>
             </a:r>
           </a:p>
@@ -7089,7 +7127,24 @@
               </a:defRPr>
             </a:pPr>
             <a:r>
-              <a:t>📱 Khách hàng (Customer)</a:t>
+              <a:rPr sz="1200" dirty="0"/>
+              <a:t>📱 </a:t>
+            </a:r>
+            <a:r>
+              <a:rPr sz="1200" dirty="0" err="1"/>
+              <a:t>Khách</a:t>
+            </a:r>
+            <a:r>
+              <a:rPr sz="1200" dirty="0"/>
+              <a:t> </a:t>
+            </a:r>
+            <a:r>
+              <a:rPr sz="1200" dirty="0" err="1"/>
+              <a:t>hàng</a:t>
+            </a:r>
+            <a:r>
+              <a:rPr sz="1200" dirty="0"/>
+              <a:t> (Customer)</a:t>
             </a:r>
           </a:p>
           <a:p>
@@ -7105,8 +7160,58 @@
               </a:defRPr>
             </a:pPr>
             <a:r>
-              <a:t>Quét mã QR tại bàn, xem menu, gọi món</a:t>
-            </a:r>
+              <a:rPr sz="1050" dirty="0" err="1"/>
+              <a:t>Quét</a:t>
+            </a:r>
+            <a:r>
+              <a:rPr sz="1050" dirty="0"/>
+              <a:t> </a:t>
+            </a:r>
+            <a:r>
+              <a:rPr sz="1050" dirty="0" err="1"/>
+              <a:t>mã</a:t>
+            </a:r>
+            <a:r>
+              <a:rPr sz="1050" dirty="0"/>
+              <a:t> QR </a:t>
+            </a:r>
+            <a:r>
+              <a:rPr sz="1050" dirty="0" err="1"/>
+              <a:t>tại</a:t>
+            </a:r>
+            <a:r>
+              <a:rPr sz="1050" dirty="0"/>
+              <a:t> </a:t>
+            </a:r>
+            <a:r>
+              <a:rPr sz="1050" dirty="0" err="1"/>
+              <a:t>bàn</a:t>
+            </a:r>
+            <a:r>
+              <a:rPr sz="1050" dirty="0"/>
+              <a:t>, </a:t>
+            </a:r>
+            <a:r>
+              <a:rPr sz="1050" dirty="0" err="1"/>
+              <a:t>xem</a:t>
+            </a:r>
+            <a:r>
+              <a:rPr sz="1050" dirty="0"/>
+              <a:t> menu, </a:t>
+            </a:r>
+            <a:r>
+              <a:rPr sz="1050" dirty="0" err="1"/>
+              <a:t>gọi</a:t>
+            </a:r>
+            <a:r>
+              <a:rPr sz="1050" dirty="0"/>
+              <a:t> </a:t>
+            </a:r>
+            <a:r>
+              <a:rPr sz="1050" dirty="0" err="1"/>
+              <a:t>món</a:t>
+            </a:r>
+            <a:endParaRPr sz="1050" dirty="0"/>
           </a:p>
         </p:txBody>
       </p:sp>

</xml_diff>

<commit_message>
feat: add login, registration, and order management components with backend controllers and routes
</commit_message>
<xml_diff>
--- a/BaoCao_TongQuan_DoAn_BackEnd_RoyalBistro.pptx
+++ b/BaoCao_TongQuan_DoAn_BackEnd_RoyalBistro.pptx
@@ -10,8 +10,7 @@
     <p:sldId id="258" r:id="rId4"/>
     <p:sldId id="260" r:id="rId5"/>
     <p:sldId id="262" r:id="rId6"/>
-    <p:sldId id="263" r:id="rId7"/>
-    <p:sldId id="267" r:id="rId8"/>
+    <p:sldId id="267" r:id="rId7"/>
   </p:sldIdLst>
   <p:sldSz cx="12192000" cy="6858000"/>
   <p:notesSz cx="6858000" cy="9144000"/>
@@ -142,16 +141,24 @@
   <pc:docChgLst>
     <pc:chgData name="Hưng Nguyễn" userId="62088adbe5b10a38" providerId="LiveId" clId="{0038B2EA-E61B-494E-8805-E1A7D9E185B2}"/>
     <pc:docChg chg="custSel delSld modSld">
-      <pc:chgData name="Hưng Nguyễn" userId="62088adbe5b10a38" providerId="LiveId" clId="{0038B2EA-E61B-494E-8805-E1A7D9E185B2}" dt="2026-10-20T02:31:04.689" v="223" actId="403"/>
+      <pc:chgData name="Hưng Nguyễn" userId="62088adbe5b10a38" providerId="LiveId" clId="{0038B2EA-E61B-494E-8805-E1A7D9E185B2}" dt="2026-10-20T02:48:13.493" v="378" actId="255"/>
       <pc:docMkLst>
         <pc:docMk/>
       </pc:docMkLst>
       <pc:sldChg chg="modSp mod">
-        <pc:chgData name="Hưng Nguyễn" userId="62088adbe5b10a38" providerId="LiveId" clId="{0038B2EA-E61B-494E-8805-E1A7D9E185B2}" dt="2026-10-20T01:50:20.361" v="211" actId="1076"/>
+        <pc:chgData name="Hưng Nguyễn" userId="62088adbe5b10a38" providerId="LiveId" clId="{0038B2EA-E61B-494E-8805-E1A7D9E185B2}" dt="2026-10-20T02:47:29.406" v="366" actId="403"/>
         <pc:sldMkLst>
           <pc:docMk/>
           <pc:sldMk cId="0" sldId="256"/>
         </pc:sldMkLst>
+        <pc:spChg chg="mod">
+          <ac:chgData name="Hưng Nguyễn" userId="62088adbe5b10a38" providerId="LiveId" clId="{0038B2EA-E61B-494E-8805-E1A7D9E185B2}" dt="2026-10-20T02:47:29.406" v="366" actId="403"/>
+          <ac:spMkLst>
+            <pc:docMk/>
+            <pc:sldMk cId="0" sldId="256"/>
+            <ac:spMk id="5" creationId="{00000000-0000-0000-0000-000000000000}"/>
+          </ac:spMkLst>
+        </pc:spChg>
         <pc:spChg chg="mod">
           <ac:chgData name="Hưng Nguyễn" userId="62088adbe5b10a38" providerId="LiveId" clId="{0038B2EA-E61B-494E-8805-E1A7D9E185B2}" dt="2026-10-20T01:50:20.361" v="211" actId="1076"/>
           <ac:spMkLst>
@@ -178,13 +185,13 @@
         </pc:spChg>
       </pc:sldChg>
       <pc:sldChg chg="modSp mod">
-        <pc:chgData name="Hưng Nguyễn" userId="62088adbe5b10a38" providerId="LiveId" clId="{0038B2EA-E61B-494E-8805-E1A7D9E185B2}" dt="2026-10-20T02:31:04.689" v="223" actId="403"/>
+        <pc:chgData name="Hưng Nguyễn" userId="62088adbe5b10a38" providerId="LiveId" clId="{0038B2EA-E61B-494E-8805-E1A7D9E185B2}" dt="2026-10-20T02:48:13.493" v="378" actId="255"/>
         <pc:sldMkLst>
           <pc:docMk/>
           <pc:sldMk cId="0" sldId="257"/>
         </pc:sldMkLst>
         <pc:spChg chg="mod">
-          <ac:chgData name="Hưng Nguyễn" userId="62088adbe5b10a38" providerId="LiveId" clId="{0038B2EA-E61B-494E-8805-E1A7D9E185B2}" dt="2026-10-20T01:18:19.206" v="17" actId="403"/>
+          <ac:chgData name="Hưng Nguyễn" userId="62088adbe5b10a38" providerId="LiveId" clId="{0038B2EA-E61B-494E-8805-E1A7D9E185B2}" dt="2026-10-20T02:48:08.828" v="377" actId="255"/>
           <ac:spMkLst>
             <pc:docMk/>
             <pc:sldMk cId="0" sldId="257"/>
@@ -192,7 +199,7 @@
           </ac:spMkLst>
         </pc:spChg>
         <pc:spChg chg="mod">
-          <ac:chgData name="Hưng Nguyễn" userId="62088adbe5b10a38" providerId="LiveId" clId="{0038B2EA-E61B-494E-8805-E1A7D9E185B2}" dt="2026-10-20T01:18:27.375" v="21" actId="403"/>
+          <ac:chgData name="Hưng Nguyễn" userId="62088adbe5b10a38" providerId="LiveId" clId="{0038B2EA-E61B-494E-8805-E1A7D9E185B2}" dt="2026-10-20T02:48:13.493" v="378" actId="255"/>
           <ac:spMkLst>
             <pc:docMk/>
             <pc:sldMk cId="0" sldId="257"/>
@@ -303,7 +310,7 @@
         </pc:spChg>
       </pc:sldChg>
       <pc:sldChg chg="modSp mod">
-        <pc:chgData name="Hưng Nguyễn" userId="62088adbe5b10a38" providerId="LiveId" clId="{0038B2EA-E61B-494E-8805-E1A7D9E185B2}" dt="2026-10-20T01:28:18.401" v="187" actId="403"/>
+        <pc:chgData name="Hưng Nguyễn" userId="62088adbe5b10a38" providerId="LiveId" clId="{0038B2EA-E61B-494E-8805-E1A7D9E185B2}" dt="2026-10-20T02:37:05.896" v="226" actId="14100"/>
         <pc:sldMkLst>
           <pc:docMk/>
           <pc:sldMk cId="0" sldId="260"/>
@@ -325,7 +332,7 @@
           </ac:spMkLst>
         </pc:spChg>
         <pc:picChg chg="mod">
-          <ac:chgData name="Hưng Nguyễn" userId="62088adbe5b10a38" providerId="LiveId" clId="{0038B2EA-E61B-494E-8805-E1A7D9E185B2}" dt="2026-10-20T01:20:06.853" v="22" actId="1076"/>
+          <ac:chgData name="Hưng Nguyễn" userId="62088adbe5b10a38" providerId="LiveId" clId="{0038B2EA-E61B-494E-8805-E1A7D9E185B2}" dt="2026-10-20T02:37:05.896" v="226" actId="14100"/>
           <ac:picMkLst>
             <pc:docMk/>
             <pc:sldMk cId="0" sldId="260"/>
@@ -427,8 +434,8 @@
           </ac:picMkLst>
         </pc:picChg>
       </pc:sldChg>
-      <pc:sldChg chg="addSp delSp modSp mod">
-        <pc:chgData name="Hưng Nguyễn" userId="62088adbe5b10a38" providerId="LiveId" clId="{0038B2EA-E61B-494E-8805-E1A7D9E185B2}" dt="2026-10-20T01:28:00.947" v="182" actId="207"/>
+      <pc:sldChg chg="addSp delSp modSp del mod">
+        <pc:chgData name="Hưng Nguyễn" userId="62088adbe5b10a38" providerId="LiveId" clId="{0038B2EA-E61B-494E-8805-E1A7D9E185B2}" dt="2026-10-20T02:36:47.003" v="224" actId="2696"/>
         <pc:sldMkLst>
           <pc:docMk/>
           <pc:sldMk cId="0" sldId="263"/>
@@ -3754,6 +3761,7 @@
               </a:defRPr>
             </a:pPr>
             <a:r>
+              <a:rPr dirty="0"/>
               <a:t>BÁO CÁO ĐỒ ÁN MÔN HỌC: CHUYÊN ĐỀ BACK-END</a:t>
             </a:r>
           </a:p>
@@ -3770,27 +3778,15 @@
               </a:defRPr>
             </a:pPr>
             <a:r>
-              <a:t>XÂY DỰNG HỆ THỐNG BACK-END CHO PHẦN MỀM</a:t>
-            </a:r>
-            <a:br/>
-            <a:r>
-              <a:t>QUẢN LÝ NHÀ HÀNG &amp; GỌI MÓN (ROYAL BISTRO)</a:t>
-            </a:r>
-          </a:p>
-          <a:p>
-            <a:pPr algn="ctr">
-              <a:spcBef>
-                <a:spcPts val="600"/>
-              </a:spcBef>
-              <a:defRPr sz="1200">
-                <a:solidFill>
-                  <a:srgbClr val="475569"/>
-                </a:solidFill>
-                <a:latin typeface="Segoe UI"/>
-              </a:defRPr>
-            </a:pPr>
-            <a:r>
-              <a:t>Kiến trúc máy chủ RESTful API &amp; WebSocket Realtime • Điều phối Bếp KDS • Tự động trừ kho định lượng BOM</a:t>
+              <a:rPr sz="3600" dirty="0"/>
+              <a:t>XÂY DỰNG HỆ THỐNG</a:t>
+            </a:r>
+            <a:br>
+              <a:rPr sz="3600" dirty="0"/>
+            </a:br>
+            <a:r>
+              <a:rPr sz="3600" dirty="0"/>
+              <a:t>QUẢN LÝ NHÀ HÀNG(ROYAL BISTRO)</a:t>
             </a:r>
           </a:p>
         </p:txBody>
@@ -5141,8 +5137,16 @@
               </a:defRPr>
             </a:pPr>
             <a:r>
-              <a:rPr sz="1400" dirty="0"/>
-              <a:t>⚠️ 4 BẤT CẬP QUY TRÌNH TRUYỀN THỐNG</a:t>
+              <a:rPr sz="1600" dirty="0"/>
+              <a:t>⚠️ </a:t>
+            </a:r>
+            <a:r>
+              <a:rPr lang="en-US" sz="1600" dirty="0"/>
+              <a:t>3</a:t>
+            </a:r>
+            <a:r>
+              <a:rPr sz="1600" dirty="0"/>
+              <a:t> BẤT CẬP QUY TRÌNH TRUYỀN THỐNG</a:t>
             </a:r>
           </a:p>
           <a:p>
@@ -5158,51 +5162,51 @@
               </a:defRPr>
             </a:pPr>
             <a:r>
-              <a:rPr sz="1400" dirty="0"/>
+              <a:rPr sz="1600" dirty="0"/>
               <a:t>• </a:t>
             </a:r>
             <a:r>
-              <a:rPr sz="1400" dirty="0" err="1"/>
+              <a:rPr sz="1600" dirty="0" err="1"/>
               <a:t>Tắc</a:t>
             </a:r>
             <a:r>
-              <a:rPr sz="1400" dirty="0"/>
-              <a:t> </a:t>
-            </a:r>
-            <a:r>
-              <a:rPr sz="1400" dirty="0" err="1"/>
+              <a:rPr sz="1600" dirty="0"/>
+              <a:t> </a:t>
+            </a:r>
+            <a:r>
+              <a:rPr sz="1600" dirty="0" err="1"/>
               <a:t>nghẽn</a:t>
             </a:r>
             <a:r>
-              <a:rPr sz="1400" dirty="0"/>
-              <a:t> </a:t>
-            </a:r>
-            <a:r>
-              <a:rPr sz="1400" dirty="0" err="1"/>
+              <a:rPr sz="1600" dirty="0"/>
+              <a:t> </a:t>
+            </a:r>
+            <a:r>
+              <a:rPr sz="1600" dirty="0" err="1"/>
               <a:t>giờ</a:t>
             </a:r>
             <a:r>
-              <a:rPr sz="1400" dirty="0"/>
-              <a:t> </a:t>
-            </a:r>
-            <a:r>
-              <a:rPr sz="1400" dirty="0" err="1"/>
+              <a:rPr sz="1600" dirty="0"/>
+              <a:t> </a:t>
+            </a:r>
+            <a:r>
+              <a:rPr sz="1600" dirty="0" err="1"/>
               <a:t>cao</a:t>
             </a:r>
             <a:r>
-              <a:rPr sz="1400" dirty="0"/>
-              <a:t> </a:t>
-            </a:r>
-            <a:r>
-              <a:rPr sz="1400" dirty="0" err="1"/>
+              <a:rPr sz="1600" dirty="0"/>
+              <a:t> </a:t>
+            </a:r>
+            <a:r>
+              <a:rPr sz="1600" dirty="0" err="1"/>
               <a:t>điểm</a:t>
             </a:r>
             <a:r>
-              <a:rPr sz="1400" dirty="0"/>
+              <a:rPr sz="1600" dirty="0"/>
               <a:t>: </a:t>
             </a:r>
             <a:r>
-              <a:rPr sz="1400" b="0" dirty="0" err="1">
+              <a:rPr sz="1600" b="0" dirty="0" err="1">
                 <a:solidFill>
                   <a:srgbClr val="475569"/>
                 </a:solidFill>
@@ -5210,7 +5214,7 @@
               <a:t>Ghi</a:t>
             </a:r>
             <a:r>
-              <a:rPr sz="1400" b="0" dirty="0">
+              <a:rPr sz="1600" b="0" dirty="0">
                 <a:solidFill>
                   <a:srgbClr val="475569"/>
                 </a:solidFill>
@@ -5218,7 +5222,7 @@
               <a:t> bill </a:t>
             </a:r>
             <a:r>
-              <a:rPr sz="1400" b="0" dirty="0" err="1">
+              <a:rPr sz="1600" b="0" dirty="0" err="1">
                 <a:solidFill>
                   <a:srgbClr val="475569"/>
                 </a:solidFill>
@@ -5226,15 +5230,15 @@
               <a:t>giấy</a:t>
             </a:r>
             <a:r>
-              <a:rPr sz="1400" b="0" dirty="0">
-                <a:solidFill>
-                  <a:srgbClr val="475569"/>
-                </a:solidFill>
-              </a:rPr>
-              <a:t> </a:t>
-            </a:r>
-            <a:r>
-              <a:rPr sz="1400" b="0" dirty="0" err="1">
+              <a:rPr sz="1600" b="0" dirty="0">
+                <a:solidFill>
+                  <a:srgbClr val="475569"/>
+                </a:solidFill>
+              </a:rPr>
+              <a:t> </a:t>
+            </a:r>
+            <a:r>
+              <a:rPr sz="1600" b="0" dirty="0" err="1">
                 <a:solidFill>
                   <a:srgbClr val="475569"/>
                 </a:solidFill>
@@ -5242,15 +5246,15 @@
               <a:t>chậm</a:t>
             </a:r>
             <a:r>
-              <a:rPr sz="1400" b="0" dirty="0">
-                <a:solidFill>
-                  <a:srgbClr val="475569"/>
-                </a:solidFill>
-              </a:rPr>
-              <a:t> </a:t>
-            </a:r>
-            <a:r>
-              <a:rPr sz="1400" b="0" dirty="0" err="1">
+              <a:rPr sz="1600" b="0" dirty="0">
+                <a:solidFill>
+                  <a:srgbClr val="475569"/>
+                </a:solidFill>
+              </a:rPr>
+              <a:t> </a:t>
+            </a:r>
+            <a:r>
+              <a:rPr sz="1600" b="0" dirty="0" err="1">
                 <a:solidFill>
                   <a:srgbClr val="475569"/>
                 </a:solidFill>
@@ -5258,7 +5262,7 @@
               <a:t>trễ</a:t>
             </a:r>
             <a:r>
-              <a:rPr sz="1400" b="0" dirty="0">
+              <a:rPr sz="1600" b="0" dirty="0">
                 <a:solidFill>
                   <a:srgbClr val="475569"/>
                 </a:solidFill>
@@ -5266,7 +5270,7 @@
               <a:t>, </a:t>
             </a:r>
             <a:r>
-              <a:rPr sz="1400" b="0" dirty="0" err="1">
+              <a:rPr sz="1600" b="0" dirty="0" err="1">
                 <a:solidFill>
                   <a:srgbClr val="475569"/>
                 </a:solidFill>
@@ -5274,15 +5278,15 @@
               <a:t>khách</a:t>
             </a:r>
             <a:r>
-              <a:rPr sz="1400" b="0" dirty="0">
-                <a:solidFill>
-                  <a:srgbClr val="475569"/>
-                </a:solidFill>
-              </a:rPr>
-              <a:t> </a:t>
-            </a:r>
-            <a:r>
-              <a:rPr sz="1400" b="0" dirty="0" err="1">
+              <a:rPr sz="1600" b="0" dirty="0">
+                <a:solidFill>
+                  <a:srgbClr val="475569"/>
+                </a:solidFill>
+              </a:rPr>
+              <a:t> </a:t>
+            </a:r>
+            <a:r>
+              <a:rPr sz="1600" b="0" dirty="0" err="1">
                 <a:solidFill>
                   <a:srgbClr val="475569"/>
                 </a:solidFill>
@@ -5290,15 +5294,15 @@
               <a:t>chờ</a:t>
             </a:r>
             <a:r>
-              <a:rPr sz="1400" b="0" dirty="0">
-                <a:solidFill>
-                  <a:srgbClr val="475569"/>
-                </a:solidFill>
-              </a:rPr>
-              <a:t> </a:t>
-            </a:r>
-            <a:r>
-              <a:rPr sz="1400" b="0" dirty="0" err="1">
+              <a:rPr sz="1600" b="0" dirty="0">
+                <a:solidFill>
+                  <a:srgbClr val="475569"/>
+                </a:solidFill>
+              </a:rPr>
+              <a:t> </a:t>
+            </a:r>
+            <a:r>
+              <a:rPr sz="1600" b="0" dirty="0" err="1">
                 <a:solidFill>
                   <a:srgbClr val="475569"/>
                 </a:solidFill>
@@ -5306,7 +5310,7 @@
               <a:t>lâu</a:t>
             </a:r>
             <a:r>
-              <a:rPr sz="1400" b="0" dirty="0">
+              <a:rPr sz="1600" b="0" dirty="0">
                 <a:solidFill>
                   <a:srgbClr val="475569"/>
                 </a:solidFill>
@@ -5314,7 +5318,7 @@
               <a:t>, </a:t>
             </a:r>
             <a:r>
-              <a:rPr sz="1400" b="0" dirty="0" err="1">
+              <a:rPr sz="1600" b="0" dirty="0" err="1">
                 <a:solidFill>
                   <a:srgbClr val="475569"/>
                 </a:solidFill>
@@ -5322,15 +5326,15 @@
               <a:t>giảm</a:t>
             </a:r>
             <a:r>
-              <a:rPr sz="1400" b="0" dirty="0">
-                <a:solidFill>
-                  <a:srgbClr val="475569"/>
-                </a:solidFill>
-              </a:rPr>
-              <a:t> </a:t>
-            </a:r>
-            <a:r>
-              <a:rPr sz="1400" b="0" dirty="0" err="1">
+              <a:rPr sz="1600" b="0" dirty="0">
+                <a:solidFill>
+                  <a:srgbClr val="475569"/>
+                </a:solidFill>
+              </a:rPr>
+              <a:t> </a:t>
+            </a:r>
+            <a:r>
+              <a:rPr sz="1600" b="0" dirty="0" err="1">
                 <a:solidFill>
                   <a:srgbClr val="475569"/>
                 </a:solidFill>
@@ -5338,7 +5342,7 @@
               <a:t>vòng</a:t>
             </a:r>
             <a:r>
-              <a:rPr sz="1400" b="0" dirty="0">
+              <a:rPr sz="1600" b="0" dirty="0">
                 <a:solidFill>
                   <a:srgbClr val="475569"/>
                 </a:solidFill>
@@ -5346,7 +5350,7 @@
               <a:t> quay </a:t>
             </a:r>
             <a:r>
-              <a:rPr sz="1400" b="0" dirty="0" err="1">
+              <a:rPr sz="1600" b="0" dirty="0" err="1">
                 <a:solidFill>
                   <a:srgbClr val="475569"/>
                 </a:solidFill>
@@ -5354,7 +5358,7 @@
               <a:t>bàn</a:t>
             </a:r>
             <a:r>
-              <a:rPr sz="1400" b="0" dirty="0">
+              <a:rPr sz="1600" b="0" dirty="0">
                 <a:solidFill>
                   <a:srgbClr val="475569"/>
                 </a:solidFill>
@@ -5375,43 +5379,43 @@
               </a:defRPr>
             </a:pPr>
             <a:r>
-              <a:rPr sz="1400" dirty="0"/>
+              <a:rPr sz="1600" dirty="0"/>
               <a:t>• Sai </a:t>
             </a:r>
             <a:r>
-              <a:rPr sz="1400" dirty="0" err="1"/>
+              <a:rPr sz="1600" dirty="0" err="1"/>
               <a:t>sót</a:t>
             </a:r>
             <a:r>
-              <a:rPr sz="1400" dirty="0"/>
-              <a:t> </a:t>
-            </a:r>
-            <a:r>
-              <a:rPr sz="1400" dirty="0" err="1"/>
+              <a:rPr sz="1600" dirty="0"/>
+              <a:t> </a:t>
+            </a:r>
+            <a:r>
+              <a:rPr sz="1600" dirty="0" err="1"/>
               <a:t>khi</a:t>
             </a:r>
             <a:r>
-              <a:rPr sz="1400" dirty="0"/>
-              <a:t> </a:t>
-            </a:r>
-            <a:r>
-              <a:rPr sz="1400" dirty="0" err="1"/>
+              <a:rPr sz="1600" dirty="0"/>
+              <a:t> </a:t>
+            </a:r>
+            <a:r>
+              <a:rPr sz="1600" dirty="0" err="1"/>
               <a:t>truyền</a:t>
             </a:r>
             <a:r>
-              <a:rPr sz="1400" dirty="0"/>
-              <a:t> </a:t>
-            </a:r>
-            <a:r>
-              <a:rPr sz="1400" dirty="0" err="1"/>
+              <a:rPr sz="1600" dirty="0"/>
+              <a:t> </a:t>
+            </a:r>
+            <a:r>
+              <a:rPr sz="1600" dirty="0" err="1"/>
               <a:t>đạt</a:t>
             </a:r>
             <a:r>
-              <a:rPr sz="1400" dirty="0"/>
+              <a:rPr sz="1600" dirty="0"/>
               <a:t>: </a:t>
             </a:r>
             <a:r>
-              <a:rPr sz="1400" b="0" dirty="0" err="1">
+              <a:rPr sz="1600" b="0" dirty="0" err="1">
                 <a:solidFill>
                   <a:srgbClr val="475569"/>
                 </a:solidFill>
@@ -5419,15 +5423,15 @@
               <a:t>Chữ</a:t>
             </a:r>
             <a:r>
-              <a:rPr sz="1400" b="0" dirty="0">
-                <a:solidFill>
-                  <a:srgbClr val="475569"/>
-                </a:solidFill>
-              </a:rPr>
-              <a:t> </a:t>
-            </a:r>
-            <a:r>
-              <a:rPr sz="1400" b="0" dirty="0" err="1">
+              <a:rPr sz="1600" b="0" dirty="0">
+                <a:solidFill>
+                  <a:srgbClr val="475569"/>
+                </a:solidFill>
+              </a:rPr>
+              <a:t> </a:t>
+            </a:r>
+            <a:r>
+              <a:rPr sz="1600" b="0" dirty="0" err="1">
                 <a:solidFill>
                   <a:srgbClr val="475569"/>
                 </a:solidFill>
@@ -5435,15 +5439,15 @@
               <a:t>viết</a:t>
             </a:r>
             <a:r>
-              <a:rPr sz="1400" b="0" dirty="0">
-                <a:solidFill>
-                  <a:srgbClr val="475569"/>
-                </a:solidFill>
-              </a:rPr>
-              <a:t> </a:t>
-            </a:r>
-            <a:r>
-              <a:rPr sz="1400" b="0" dirty="0" err="1">
+              <a:rPr sz="1600" b="0" dirty="0">
+                <a:solidFill>
+                  <a:srgbClr val="475569"/>
+                </a:solidFill>
+              </a:rPr>
+              <a:t> </a:t>
+            </a:r>
+            <a:r>
+              <a:rPr sz="1600" b="0" dirty="0" err="1">
                 <a:solidFill>
                   <a:srgbClr val="475569"/>
                 </a:solidFill>
@@ -5451,15 +5455,15 @@
               <a:t>tay</a:t>
             </a:r>
             <a:r>
-              <a:rPr sz="1400" b="0" dirty="0">
-                <a:solidFill>
-                  <a:srgbClr val="475569"/>
-                </a:solidFill>
-              </a:rPr>
-              <a:t> </a:t>
-            </a:r>
-            <a:r>
-              <a:rPr sz="1400" b="0" dirty="0" err="1">
+              <a:rPr sz="1600" b="0" dirty="0">
+                <a:solidFill>
+                  <a:srgbClr val="475569"/>
+                </a:solidFill>
+              </a:rPr>
+              <a:t> </a:t>
+            </a:r>
+            <a:r>
+              <a:rPr sz="1600" b="0" dirty="0" err="1">
                 <a:solidFill>
                   <a:srgbClr val="475569"/>
                 </a:solidFill>
@@ -5467,15 +5471,15 @@
               <a:t>khó</a:t>
             </a:r>
             <a:r>
-              <a:rPr sz="1400" b="0" dirty="0">
-                <a:solidFill>
-                  <a:srgbClr val="475569"/>
-                </a:solidFill>
-              </a:rPr>
-              <a:t> </a:t>
-            </a:r>
-            <a:r>
-              <a:rPr sz="1400" b="0" dirty="0" err="1">
+              <a:rPr sz="1600" b="0" dirty="0">
+                <a:solidFill>
+                  <a:srgbClr val="475569"/>
+                </a:solidFill>
+              </a:rPr>
+              <a:t> </a:t>
+            </a:r>
+            <a:r>
+              <a:rPr sz="1600" b="0" dirty="0" err="1">
                 <a:solidFill>
                   <a:srgbClr val="475569"/>
                 </a:solidFill>
@@ -5483,7 +5487,7 @@
               <a:t>đọc</a:t>
             </a:r>
             <a:r>
-              <a:rPr sz="1400" b="0" dirty="0">
+              <a:rPr sz="1600" b="0" dirty="0">
                 <a:solidFill>
                   <a:srgbClr val="475569"/>
                 </a:solidFill>
@@ -5491,7 +5495,7 @@
               <a:t>, </a:t>
             </a:r>
             <a:r>
-              <a:rPr sz="1400" b="0" dirty="0" err="1">
+              <a:rPr sz="1600" b="0" dirty="0" err="1">
                 <a:solidFill>
                   <a:srgbClr val="475569"/>
                 </a:solidFill>
@@ -5499,15 +5503,15 @@
               <a:t>dễ</a:t>
             </a:r>
             <a:r>
-              <a:rPr sz="1400" b="0" dirty="0">
-                <a:solidFill>
-                  <a:srgbClr val="475569"/>
-                </a:solidFill>
-              </a:rPr>
-              <a:t> </a:t>
-            </a:r>
-            <a:r>
-              <a:rPr sz="1400" b="0" dirty="0" err="1">
+              <a:rPr sz="1600" b="0" dirty="0">
+                <a:solidFill>
+                  <a:srgbClr val="475569"/>
+                </a:solidFill>
+              </a:rPr>
+              <a:t> </a:t>
+            </a:r>
+            <a:r>
+              <a:rPr sz="1600" b="0" dirty="0" err="1">
                 <a:solidFill>
                   <a:srgbClr val="475569"/>
                 </a:solidFill>
@@ -5515,15 +5519,15 @@
               <a:t>nhầm</a:t>
             </a:r>
             <a:r>
-              <a:rPr sz="1400" b="0" dirty="0">
-                <a:solidFill>
-                  <a:srgbClr val="475569"/>
-                </a:solidFill>
-              </a:rPr>
-              <a:t> </a:t>
-            </a:r>
-            <a:r>
-              <a:rPr sz="1400" b="0" dirty="0" err="1">
+              <a:rPr sz="1600" b="0" dirty="0">
+                <a:solidFill>
+                  <a:srgbClr val="475569"/>
+                </a:solidFill>
+              </a:rPr>
+              <a:t> </a:t>
+            </a:r>
+            <a:r>
+              <a:rPr sz="1600" b="0" dirty="0" err="1">
                 <a:solidFill>
                   <a:srgbClr val="475569"/>
                 </a:solidFill>
@@ -5531,15 +5535,15 @@
               <a:t>món</a:t>
             </a:r>
             <a:r>
-              <a:rPr sz="1400" b="0" dirty="0">
-                <a:solidFill>
-                  <a:srgbClr val="475569"/>
-                </a:solidFill>
-              </a:rPr>
-              <a:t> </a:t>
-            </a:r>
-            <a:r>
-              <a:rPr sz="1400" b="0" dirty="0" err="1">
+              <a:rPr sz="1600" b="0" dirty="0">
+                <a:solidFill>
+                  <a:srgbClr val="475569"/>
+                </a:solidFill>
+              </a:rPr>
+              <a:t> </a:t>
+            </a:r>
+            <a:r>
+              <a:rPr sz="1600" b="0" dirty="0" err="1">
                 <a:solidFill>
                   <a:srgbClr val="475569"/>
                 </a:solidFill>
@@ -5547,15 +5551,15 @@
               <a:t>và</a:t>
             </a:r>
             <a:r>
-              <a:rPr sz="1400" b="0" dirty="0">
-                <a:solidFill>
-                  <a:srgbClr val="475569"/>
-                </a:solidFill>
-              </a:rPr>
-              <a:t> </a:t>
-            </a:r>
-            <a:r>
-              <a:rPr sz="1400" b="0" dirty="0" err="1">
+              <a:rPr sz="1600" b="0" dirty="0">
+                <a:solidFill>
+                  <a:srgbClr val="475569"/>
+                </a:solidFill>
+              </a:rPr>
+              <a:t> </a:t>
+            </a:r>
+            <a:r>
+              <a:rPr sz="1600" b="0" dirty="0" err="1">
                 <a:solidFill>
                   <a:srgbClr val="475569"/>
                 </a:solidFill>
@@ -5563,15 +5567,15 @@
               <a:t>quên</a:t>
             </a:r>
             <a:r>
-              <a:rPr sz="1400" b="0" dirty="0">
-                <a:solidFill>
-                  <a:srgbClr val="475569"/>
-                </a:solidFill>
-              </a:rPr>
-              <a:t> </a:t>
-            </a:r>
-            <a:r>
-              <a:rPr sz="1400" b="0" dirty="0" err="1">
+              <a:rPr sz="1600" b="0" dirty="0">
+                <a:solidFill>
+                  <a:srgbClr val="475569"/>
+                </a:solidFill>
+              </a:rPr>
+              <a:t> </a:t>
+            </a:r>
+            <a:r>
+              <a:rPr sz="1600" b="0" dirty="0" err="1">
                 <a:solidFill>
                   <a:srgbClr val="475569"/>
                 </a:solidFill>
@@ -5579,15 +5583,15 @@
               <a:t>ghi</a:t>
             </a:r>
             <a:r>
-              <a:rPr sz="1400" b="0" dirty="0">
-                <a:solidFill>
-                  <a:srgbClr val="475569"/>
-                </a:solidFill>
-              </a:rPr>
-              <a:t> </a:t>
-            </a:r>
-            <a:r>
-              <a:rPr sz="1400" b="0" dirty="0" err="1">
+              <a:rPr sz="1600" b="0" dirty="0">
+                <a:solidFill>
+                  <a:srgbClr val="475569"/>
+                </a:solidFill>
+              </a:rPr>
+              <a:t> </a:t>
+            </a:r>
+            <a:r>
+              <a:rPr sz="1600" b="0" dirty="0" err="1">
                 <a:solidFill>
                   <a:srgbClr val="475569"/>
                 </a:solidFill>
@@ -5595,15 +5599,15 @@
               <a:t>chú</a:t>
             </a:r>
             <a:r>
-              <a:rPr sz="1400" b="0" dirty="0">
-                <a:solidFill>
-                  <a:srgbClr val="475569"/>
-                </a:solidFill>
-              </a:rPr>
-              <a:t> </a:t>
-            </a:r>
-            <a:r>
-              <a:rPr sz="1400" b="0" dirty="0" err="1">
+              <a:rPr sz="1600" b="0" dirty="0">
+                <a:solidFill>
+                  <a:srgbClr val="475569"/>
+                </a:solidFill>
+              </a:rPr>
+              <a:t> </a:t>
+            </a:r>
+            <a:r>
+              <a:rPr sz="1600" b="0" dirty="0" err="1">
                 <a:solidFill>
                   <a:srgbClr val="475569"/>
                 </a:solidFill>
@@ -5611,15 +5615,15 @@
               <a:t>chế</a:t>
             </a:r>
             <a:r>
-              <a:rPr sz="1400" b="0" dirty="0">
-                <a:solidFill>
-                  <a:srgbClr val="475569"/>
-                </a:solidFill>
-              </a:rPr>
-              <a:t> </a:t>
-            </a:r>
-            <a:r>
-              <a:rPr sz="1400" b="0" dirty="0" err="1">
+              <a:rPr sz="1600" b="0" dirty="0">
+                <a:solidFill>
+                  <a:srgbClr val="475569"/>
+                </a:solidFill>
+              </a:rPr>
+              <a:t> </a:t>
+            </a:r>
+            <a:r>
+              <a:rPr sz="1600" b="0" dirty="0" err="1">
                 <a:solidFill>
                   <a:srgbClr val="475569"/>
                 </a:solidFill>
@@ -5627,7 +5631,7 @@
               <a:t>biến</a:t>
             </a:r>
             <a:r>
-              <a:rPr sz="1400" b="0" dirty="0">
+              <a:rPr sz="1600" b="0" dirty="0">
                 <a:solidFill>
                   <a:srgbClr val="475569"/>
                 </a:solidFill>
@@ -5648,43 +5652,43 @@
               </a:defRPr>
             </a:pPr>
             <a:r>
-              <a:rPr sz="1400" dirty="0"/>
+              <a:rPr sz="1600" dirty="0"/>
               <a:t>• Thất </a:t>
             </a:r>
             <a:r>
-              <a:rPr sz="1400" dirty="0" err="1"/>
+              <a:rPr sz="1600" dirty="0" err="1"/>
               <a:t>thoát</a:t>
             </a:r>
             <a:r>
-              <a:rPr sz="1400" dirty="0"/>
-              <a:t> </a:t>
-            </a:r>
-            <a:r>
-              <a:rPr sz="1400" dirty="0" err="1"/>
+              <a:rPr sz="1600" dirty="0"/>
+              <a:t> </a:t>
+            </a:r>
+            <a:r>
+              <a:rPr sz="1600" dirty="0" err="1"/>
               <a:t>nguyên</a:t>
             </a:r>
             <a:r>
-              <a:rPr sz="1400" dirty="0"/>
-              <a:t> </a:t>
-            </a:r>
-            <a:r>
-              <a:rPr sz="1400" dirty="0" err="1"/>
+              <a:rPr sz="1600" dirty="0"/>
+              <a:t> </a:t>
+            </a:r>
+            <a:r>
+              <a:rPr sz="1600" dirty="0" err="1"/>
               <a:t>vật</a:t>
             </a:r>
             <a:r>
-              <a:rPr sz="1400" dirty="0"/>
-              <a:t> </a:t>
-            </a:r>
-            <a:r>
-              <a:rPr sz="1400" dirty="0" err="1"/>
+              <a:rPr sz="1600" dirty="0"/>
+              <a:t> </a:t>
+            </a:r>
+            <a:r>
+              <a:rPr sz="1600" dirty="0" err="1"/>
               <a:t>liệu</a:t>
             </a:r>
             <a:r>
-              <a:rPr sz="1400" dirty="0"/>
+              <a:rPr sz="1600" dirty="0"/>
               <a:t>: </a:t>
             </a:r>
             <a:r>
-              <a:rPr sz="1400" b="0" dirty="0" err="1">
+              <a:rPr sz="1600" b="0" dirty="0" err="1">
                 <a:solidFill>
                   <a:srgbClr val="475569"/>
                 </a:solidFill>
@@ -5692,15 +5696,15 @@
               <a:t>Không</a:t>
             </a:r>
             <a:r>
-              <a:rPr sz="1400" b="0" dirty="0">
-                <a:solidFill>
-                  <a:srgbClr val="475569"/>
-                </a:solidFill>
-              </a:rPr>
-              <a:t> </a:t>
-            </a:r>
-            <a:r>
-              <a:rPr sz="1400" b="0" dirty="0" err="1">
+              <a:rPr sz="1600" b="0" dirty="0">
+                <a:solidFill>
+                  <a:srgbClr val="475569"/>
+                </a:solidFill>
+              </a:rPr>
+              <a:t> </a:t>
+            </a:r>
+            <a:r>
+              <a:rPr sz="1600" b="0" dirty="0" err="1">
                 <a:solidFill>
                   <a:srgbClr val="475569"/>
                 </a:solidFill>
@@ -5708,15 +5712,15 @@
               <a:t>có</a:t>
             </a:r>
             <a:r>
-              <a:rPr sz="1400" b="0" dirty="0">
-                <a:solidFill>
-                  <a:srgbClr val="475569"/>
-                </a:solidFill>
-              </a:rPr>
-              <a:t> </a:t>
-            </a:r>
-            <a:r>
-              <a:rPr sz="1400" b="0" dirty="0" err="1">
+              <a:rPr sz="1600" b="0" dirty="0">
+                <a:solidFill>
+                  <a:srgbClr val="475569"/>
+                </a:solidFill>
+              </a:rPr>
+              <a:t> </a:t>
+            </a:r>
+            <a:r>
+              <a:rPr sz="1600" b="0" dirty="0" err="1">
                 <a:solidFill>
                   <a:srgbClr val="475569"/>
                 </a:solidFill>
@@ -5724,15 +5728,15 @@
               <a:t>công</a:t>
             </a:r>
             <a:r>
-              <a:rPr sz="1400" b="0" dirty="0">
-                <a:solidFill>
-                  <a:srgbClr val="475569"/>
-                </a:solidFill>
-              </a:rPr>
-              <a:t> </a:t>
-            </a:r>
-            <a:r>
-              <a:rPr sz="1400" b="0" dirty="0" err="1">
+              <a:rPr sz="1600" b="0" dirty="0">
+                <a:solidFill>
+                  <a:srgbClr val="475569"/>
+                </a:solidFill>
+              </a:rPr>
+              <a:t> </a:t>
+            </a:r>
+            <a:r>
+              <a:rPr sz="1600" b="0" dirty="0" err="1">
                 <a:solidFill>
                   <a:srgbClr val="475569"/>
                 </a:solidFill>
@@ -5740,15 +5744,15 @@
               <a:t>thức</a:t>
             </a:r>
             <a:r>
-              <a:rPr sz="1400" b="0" dirty="0">
-                <a:solidFill>
-                  <a:srgbClr val="475569"/>
-                </a:solidFill>
-              </a:rPr>
-              <a:t> </a:t>
-            </a:r>
-            <a:r>
-              <a:rPr sz="1400" b="0" dirty="0" err="1">
+              <a:rPr sz="1600" b="0" dirty="0">
+                <a:solidFill>
+                  <a:srgbClr val="475569"/>
+                </a:solidFill>
+              </a:rPr>
+              <a:t> </a:t>
+            </a:r>
+            <a:r>
+              <a:rPr sz="1600" b="0" dirty="0" err="1">
                 <a:solidFill>
                   <a:srgbClr val="475569"/>
                 </a:solidFill>
@@ -5756,15 +5760,15 @@
               <a:t>định</a:t>
             </a:r>
             <a:r>
-              <a:rPr sz="1400" b="0" dirty="0">
-                <a:solidFill>
-                  <a:srgbClr val="475569"/>
-                </a:solidFill>
-              </a:rPr>
-              <a:t> </a:t>
-            </a:r>
-            <a:r>
-              <a:rPr sz="1400" b="0" dirty="0" err="1">
+              <a:rPr sz="1600" b="0" dirty="0">
+                <a:solidFill>
+                  <a:srgbClr val="475569"/>
+                </a:solidFill>
+              </a:rPr>
+              <a:t> </a:t>
+            </a:r>
+            <a:r>
+              <a:rPr sz="1600" b="0" dirty="0" err="1">
                 <a:solidFill>
                   <a:srgbClr val="475569"/>
                 </a:solidFill>
@@ -5772,7 +5776,7 @@
               <a:t>lượng</a:t>
             </a:r>
             <a:r>
-              <a:rPr sz="1400" b="0" dirty="0">
+              <a:rPr sz="1600" b="0" dirty="0">
                 <a:solidFill>
                   <a:srgbClr val="475569"/>
                 </a:solidFill>
@@ -5780,7 +5784,7 @@
               <a:t> (BOM) </a:t>
             </a:r>
             <a:r>
-              <a:rPr sz="1400" b="0" dirty="0" err="1">
+              <a:rPr sz="1600" b="0" dirty="0" err="1">
                 <a:solidFill>
                   <a:srgbClr val="475569"/>
                 </a:solidFill>
@@ -5788,15 +5792,15 @@
               <a:t>gắn</a:t>
             </a:r>
             <a:r>
-              <a:rPr sz="1400" b="0" dirty="0">
-                <a:solidFill>
-                  <a:srgbClr val="475569"/>
-                </a:solidFill>
-              </a:rPr>
-              <a:t> </a:t>
-            </a:r>
-            <a:r>
-              <a:rPr sz="1400" b="0" dirty="0" err="1">
+              <a:rPr sz="1600" b="0" dirty="0">
+                <a:solidFill>
+                  <a:srgbClr val="475569"/>
+                </a:solidFill>
+              </a:rPr>
+              <a:t> </a:t>
+            </a:r>
+            <a:r>
+              <a:rPr sz="1600" b="0" dirty="0" err="1">
                 <a:solidFill>
                   <a:srgbClr val="475569"/>
                 </a:solidFill>
@@ -5804,15 +5808,15 @@
               <a:t>liền</a:t>
             </a:r>
             <a:r>
-              <a:rPr sz="1400" b="0" dirty="0">
-                <a:solidFill>
-                  <a:srgbClr val="475569"/>
-                </a:solidFill>
-              </a:rPr>
-              <a:t> </a:t>
-            </a:r>
-            <a:r>
-              <a:rPr sz="1400" b="0" dirty="0" err="1">
+              <a:rPr sz="1600" b="0" dirty="0">
+                <a:solidFill>
+                  <a:srgbClr val="475569"/>
+                </a:solidFill>
+              </a:rPr>
+              <a:t> </a:t>
+            </a:r>
+            <a:r>
+              <a:rPr sz="1600" b="0" dirty="0" err="1">
                 <a:solidFill>
                   <a:srgbClr val="475569"/>
                 </a:solidFill>
@@ -5820,15 +5824,15 @@
               <a:t>với</a:t>
             </a:r>
             <a:r>
-              <a:rPr sz="1400" b="0" dirty="0">
-                <a:solidFill>
-                  <a:srgbClr val="475569"/>
-                </a:solidFill>
-              </a:rPr>
-              <a:t> </a:t>
-            </a:r>
-            <a:r>
-              <a:rPr sz="1400" b="0" dirty="0" err="1">
+              <a:rPr sz="1600" b="0" dirty="0">
+                <a:solidFill>
+                  <a:srgbClr val="475569"/>
+                </a:solidFill>
+              </a:rPr>
+              <a:t> </a:t>
+            </a:r>
+            <a:r>
+              <a:rPr sz="1600" b="0" dirty="0" err="1">
                 <a:solidFill>
                   <a:srgbClr val="475569"/>
                 </a:solidFill>
@@ -5836,15 +5840,15 @@
               <a:t>tồn</a:t>
             </a:r>
             <a:r>
-              <a:rPr sz="1400" b="0" dirty="0">
-                <a:solidFill>
-                  <a:srgbClr val="475569"/>
-                </a:solidFill>
-              </a:rPr>
-              <a:t> </a:t>
-            </a:r>
-            <a:r>
-              <a:rPr sz="1400" b="0" dirty="0" err="1">
+              <a:rPr sz="1600" b="0" dirty="0">
+                <a:solidFill>
+                  <a:srgbClr val="475569"/>
+                </a:solidFill>
+              </a:rPr>
+              <a:t> </a:t>
+            </a:r>
+            <a:r>
+              <a:rPr sz="1600" b="0" dirty="0" err="1">
                 <a:solidFill>
                   <a:srgbClr val="475569"/>
                 </a:solidFill>
@@ -5852,288 +5856,7 @@
               <a:t>kho</a:t>
             </a:r>
             <a:r>
-              <a:rPr sz="1400" b="0" dirty="0">
-                <a:solidFill>
-                  <a:srgbClr val="475569"/>
-                </a:solidFill>
-              </a:rPr>
-              <a:t>.</a:t>
-            </a:r>
-          </a:p>
-          <a:p>
-            <a:pPr>
-              <a:spcBef>
-                <a:spcPts val="1000"/>
-              </a:spcBef>
-              <a:defRPr sz="1050" b="1">
-                <a:solidFill>
-                  <a:srgbClr val="0F172A"/>
-                </a:solidFill>
-                <a:latin typeface="Segoe UI"/>
-              </a:defRPr>
-            </a:pPr>
-            <a:r>
-              <a:rPr sz="1400" dirty="0"/>
-              <a:t>• </a:t>
-            </a:r>
-            <a:r>
-              <a:rPr sz="1400" dirty="0" err="1"/>
-              <a:t>Thiếu</a:t>
-            </a:r>
-            <a:r>
-              <a:rPr sz="1400" dirty="0"/>
-              <a:t> </a:t>
-            </a:r>
-            <a:r>
-              <a:rPr sz="1400" dirty="0" err="1"/>
-              <a:t>số</a:t>
-            </a:r>
-            <a:r>
-              <a:rPr sz="1400" dirty="0"/>
-              <a:t> </a:t>
-            </a:r>
-            <a:r>
-              <a:rPr sz="1400" dirty="0" err="1"/>
-              <a:t>liệu</a:t>
-            </a:r>
-            <a:r>
-              <a:rPr sz="1400" dirty="0"/>
-              <a:t> </a:t>
-            </a:r>
-            <a:r>
-              <a:rPr sz="1400" dirty="0" err="1"/>
-              <a:t>tức</a:t>
-            </a:r>
-            <a:r>
-              <a:rPr sz="1400" dirty="0"/>
-              <a:t> </a:t>
-            </a:r>
-            <a:r>
-              <a:rPr sz="1400" dirty="0" err="1"/>
-              <a:t>thời</a:t>
-            </a:r>
-            <a:r>
-              <a:rPr sz="1400" dirty="0"/>
-              <a:t>: </a:t>
-            </a:r>
-            <a:r>
-              <a:rPr sz="1400" b="0" dirty="0" err="1">
-                <a:solidFill>
-                  <a:srgbClr val="475569"/>
-                </a:solidFill>
-              </a:rPr>
-              <a:t>Không</a:t>
-            </a:r>
-            <a:r>
-              <a:rPr sz="1400" b="0" dirty="0">
-                <a:solidFill>
-                  <a:srgbClr val="475569"/>
-                </a:solidFill>
-              </a:rPr>
-              <a:t> </a:t>
-            </a:r>
-            <a:r>
-              <a:rPr sz="1400" b="0" dirty="0" err="1">
-                <a:solidFill>
-                  <a:srgbClr val="475569"/>
-                </a:solidFill>
-              </a:rPr>
-              <a:t>nắm</a:t>
-            </a:r>
-            <a:r>
-              <a:rPr sz="1400" b="0" dirty="0">
-                <a:solidFill>
-                  <a:srgbClr val="475569"/>
-                </a:solidFill>
-              </a:rPr>
-              <a:t> </a:t>
-            </a:r>
-            <a:r>
-              <a:rPr sz="1400" b="0" dirty="0" err="1">
-                <a:solidFill>
-                  <a:srgbClr val="475569"/>
-                </a:solidFill>
-              </a:rPr>
-              <a:t>được</a:t>
-            </a:r>
-            <a:r>
-              <a:rPr sz="1400" b="0" dirty="0">
-                <a:solidFill>
-                  <a:srgbClr val="475569"/>
-                </a:solidFill>
-              </a:rPr>
-              <a:t> </a:t>
-            </a:r>
-            <a:r>
-              <a:rPr sz="1400" b="0" dirty="0" err="1">
-                <a:solidFill>
-                  <a:srgbClr val="475569"/>
-                </a:solidFill>
-              </a:rPr>
-              <a:t>doanh</a:t>
-            </a:r>
-            <a:r>
-              <a:rPr sz="1400" b="0" dirty="0">
-                <a:solidFill>
-                  <a:srgbClr val="475569"/>
-                </a:solidFill>
-              </a:rPr>
-              <a:t> </a:t>
-            </a:r>
-            <a:r>
-              <a:rPr sz="1400" b="0" dirty="0" err="1">
-                <a:solidFill>
-                  <a:srgbClr val="475569"/>
-                </a:solidFill>
-              </a:rPr>
-              <a:t>số</a:t>
-            </a:r>
-            <a:r>
-              <a:rPr sz="1400" b="0" dirty="0">
-                <a:solidFill>
-                  <a:srgbClr val="475569"/>
-                </a:solidFill>
-              </a:rPr>
-              <a:t>, </a:t>
-            </a:r>
-            <a:r>
-              <a:rPr sz="1400" b="0" dirty="0" err="1">
-                <a:solidFill>
-                  <a:srgbClr val="475569"/>
-                </a:solidFill>
-              </a:rPr>
-              <a:t>tồn</a:t>
-            </a:r>
-            <a:r>
-              <a:rPr sz="1400" b="0" dirty="0">
-                <a:solidFill>
-                  <a:srgbClr val="475569"/>
-                </a:solidFill>
-              </a:rPr>
-              <a:t> </a:t>
-            </a:r>
-            <a:r>
-              <a:rPr sz="1400" b="0" dirty="0" err="1">
-                <a:solidFill>
-                  <a:srgbClr val="475569"/>
-                </a:solidFill>
-              </a:rPr>
-              <a:t>kho</a:t>
-            </a:r>
-            <a:r>
-              <a:rPr sz="1400" b="0" dirty="0">
-                <a:solidFill>
-                  <a:srgbClr val="475569"/>
-                </a:solidFill>
-              </a:rPr>
-              <a:t> </a:t>
-            </a:r>
-            <a:r>
-              <a:rPr sz="1400" b="0" dirty="0" err="1">
-                <a:solidFill>
-                  <a:srgbClr val="475569"/>
-                </a:solidFill>
-              </a:rPr>
-              <a:t>và</a:t>
-            </a:r>
-            <a:r>
-              <a:rPr sz="1400" b="0" dirty="0">
-                <a:solidFill>
-                  <a:srgbClr val="475569"/>
-                </a:solidFill>
-              </a:rPr>
-              <a:t> </a:t>
-            </a:r>
-            <a:r>
-              <a:rPr sz="1400" b="0" dirty="0" err="1">
-                <a:solidFill>
-                  <a:srgbClr val="475569"/>
-                </a:solidFill>
-              </a:rPr>
-              <a:t>công</a:t>
-            </a:r>
-            <a:r>
-              <a:rPr sz="1400" b="0" dirty="0">
-                <a:solidFill>
-                  <a:srgbClr val="475569"/>
-                </a:solidFill>
-              </a:rPr>
-              <a:t> </a:t>
-            </a:r>
-            <a:r>
-              <a:rPr sz="1400" b="0" dirty="0" err="1">
-                <a:solidFill>
-                  <a:srgbClr val="475569"/>
-                </a:solidFill>
-              </a:rPr>
-              <a:t>nợ</a:t>
-            </a:r>
-            <a:r>
-              <a:rPr sz="1400" b="0" dirty="0">
-                <a:solidFill>
-                  <a:srgbClr val="475569"/>
-                </a:solidFill>
-              </a:rPr>
-              <a:t> </a:t>
-            </a:r>
-            <a:r>
-              <a:rPr sz="1400" b="0" dirty="0" err="1">
-                <a:solidFill>
-                  <a:srgbClr val="475569"/>
-                </a:solidFill>
-              </a:rPr>
-              <a:t>theo</a:t>
-            </a:r>
-            <a:r>
-              <a:rPr sz="1400" b="0" dirty="0">
-                <a:solidFill>
-                  <a:srgbClr val="475569"/>
-                </a:solidFill>
-              </a:rPr>
-              <a:t> </a:t>
-            </a:r>
-            <a:r>
-              <a:rPr sz="1400" b="0" dirty="0" err="1">
-                <a:solidFill>
-                  <a:srgbClr val="475569"/>
-                </a:solidFill>
-              </a:rPr>
-              <a:t>thời</a:t>
-            </a:r>
-            <a:r>
-              <a:rPr sz="1400" b="0" dirty="0">
-                <a:solidFill>
-                  <a:srgbClr val="475569"/>
-                </a:solidFill>
-              </a:rPr>
-              <a:t> </a:t>
-            </a:r>
-            <a:r>
-              <a:rPr sz="1400" b="0" dirty="0" err="1">
-                <a:solidFill>
-                  <a:srgbClr val="475569"/>
-                </a:solidFill>
-              </a:rPr>
-              <a:t>gian</a:t>
-            </a:r>
-            <a:r>
-              <a:rPr sz="1400" b="0" dirty="0">
-                <a:solidFill>
-                  <a:srgbClr val="475569"/>
-                </a:solidFill>
-              </a:rPr>
-              <a:t> </a:t>
-            </a:r>
-            <a:r>
-              <a:rPr sz="1400" b="0" dirty="0" err="1">
-                <a:solidFill>
-                  <a:srgbClr val="475569"/>
-                </a:solidFill>
-              </a:rPr>
-              <a:t>thực</a:t>
-            </a:r>
-            <a:r>
-              <a:rPr sz="1400" b="0" dirty="0">
+              <a:rPr sz="1600" b="0" dirty="0">
                 <a:solidFill>
                   <a:srgbClr val="475569"/>
                 </a:solidFill>
@@ -6193,15 +5916,15 @@
               </a:defRPr>
             </a:pPr>
             <a:r>
-              <a:rPr sz="1400" dirty="0"/>
+              <a:rPr sz="1600" dirty="0"/>
               <a:t>🎯 </a:t>
             </a:r>
             <a:r>
-              <a:rPr lang="en-US" sz="1400" dirty="0"/>
+              <a:rPr lang="en-US" sz="1600" dirty="0"/>
               <a:t>3</a:t>
             </a:r>
             <a:r>
-              <a:rPr sz="1400" dirty="0"/>
+              <a:rPr sz="1600" dirty="0"/>
               <a:t> MỤC TIÊU GIẢI PHÁP ROYAL BISTRO</a:t>
             </a:r>
           </a:p>
@@ -9459,8 +9182,8 @@
         </p:blipFill>
         <p:spPr>
           <a:xfrm>
-            <a:off x="5821985" y="2469113"/>
-            <a:ext cx="5425135" cy="3044719"/>
+            <a:off x="5760720" y="2469113"/>
+            <a:ext cx="5669280" cy="3181739"/>
           </a:xfrm>
           <a:prstGeom prst="rect">
             <a:avLst/>
@@ -10820,838 +10543,6 @@
 </file>
 
 <file path=ppt/slides/slide6.xml><?xml version="1.0" encoding="utf-8"?>
-<p:sld xmlns:a="http://schemas.openxmlformats.org/drawingml/2006/main" xmlns:r="http://schemas.openxmlformats.org/officeDocument/2006/relationships" xmlns:p="http://schemas.openxmlformats.org/presentationml/2006/main">
-  <p:cSld>
-    <p:spTree>
-      <p:nvGrpSpPr>
-        <p:cNvPr id="1" name=""/>
-        <p:cNvGrpSpPr/>
-        <p:nvPr/>
-      </p:nvGrpSpPr>
-      <p:grpSpPr>
-        <a:xfrm>
-          <a:off x="0" y="0"/>
-          <a:ext cx="0" cy="0"/>
-          <a:chOff x="0" y="0"/>
-          <a:chExt cx="0" cy="0"/>
-        </a:xfrm>
-      </p:grpSpPr>
-      <p:sp>
-        <p:nvSpPr>
-          <p:cNvPr id="2" name="Rectangle 1"/>
-          <p:cNvSpPr/>
-          <p:nvPr/>
-        </p:nvSpPr>
-        <p:spPr>
-          <a:xfrm>
-            <a:off x="0" y="0"/>
-            <a:ext cx="12191695" cy="6858000"/>
-          </a:xfrm>
-          <a:prstGeom prst="rect">
-            <a:avLst/>
-          </a:prstGeom>
-          <a:solidFill>
-            <a:srgbClr val="F8FAFC"/>
-          </a:solidFill>
-          <a:ln>
-            <a:noFill/>
-          </a:ln>
-        </p:spPr>
-        <p:style>
-          <a:lnRef idx="1">
-            <a:schemeClr val="accent1"/>
-          </a:lnRef>
-          <a:fillRef idx="3">
-            <a:schemeClr val="accent1"/>
-          </a:fillRef>
-          <a:effectRef idx="2">
-            <a:schemeClr val="accent1"/>
-          </a:effectRef>
-          <a:fontRef idx="minor">
-            <a:schemeClr val="lt1"/>
-          </a:fontRef>
-        </p:style>
-        <p:txBody>
-          <a:bodyPr rtlCol="0" anchor="ctr"/>
-          <a:lstStyle/>
-          <a:p>
-            <a:pPr algn="ctr"/>
-            <a:endParaRPr/>
-          </a:p>
-        </p:txBody>
-      </p:sp>
-      <p:sp>
-        <p:nvSpPr>
-          <p:cNvPr id="3" name="Rectangle 2"/>
-          <p:cNvSpPr/>
-          <p:nvPr/>
-        </p:nvSpPr>
-        <p:spPr>
-          <a:xfrm>
-            <a:off x="0" y="0"/>
-            <a:ext cx="12191695" cy="1051560"/>
-          </a:xfrm>
-          <a:prstGeom prst="rect">
-            <a:avLst/>
-          </a:prstGeom>
-          <a:solidFill>
-            <a:srgbClr val="FFFFFF"/>
-          </a:solidFill>
-          <a:ln w="12700">
-            <a:solidFill>
-              <a:srgbClr val="E2E8F0"/>
-            </a:solidFill>
-          </a:ln>
-        </p:spPr>
-        <p:style>
-          <a:lnRef idx="1">
-            <a:schemeClr val="accent1"/>
-          </a:lnRef>
-          <a:fillRef idx="3">
-            <a:schemeClr val="accent1"/>
-          </a:fillRef>
-          <a:effectRef idx="2">
-            <a:schemeClr val="accent1"/>
-          </a:effectRef>
-          <a:fontRef idx="minor">
-            <a:schemeClr val="lt1"/>
-          </a:fontRef>
-        </p:style>
-        <p:txBody>
-          <a:bodyPr rtlCol="0" anchor="ctr"/>
-          <a:lstStyle/>
-          <a:p>
-            <a:pPr algn="ctr"/>
-            <a:endParaRPr/>
-          </a:p>
-        </p:txBody>
-      </p:sp>
-      <p:sp>
-        <p:nvSpPr>
-          <p:cNvPr id="4" name="Rectangle 3"/>
-          <p:cNvSpPr/>
-          <p:nvPr/>
-        </p:nvSpPr>
-        <p:spPr>
-          <a:xfrm>
-            <a:off x="0" y="0"/>
-            <a:ext cx="12191695" cy="54864"/>
-          </a:xfrm>
-          <a:prstGeom prst="rect">
-            <a:avLst/>
-          </a:prstGeom>
-          <a:solidFill>
-            <a:srgbClr val="2563EB"/>
-          </a:solidFill>
-          <a:ln>
-            <a:noFill/>
-          </a:ln>
-        </p:spPr>
-        <p:style>
-          <a:lnRef idx="1">
-            <a:schemeClr val="accent1"/>
-          </a:lnRef>
-          <a:fillRef idx="3">
-            <a:schemeClr val="accent1"/>
-          </a:fillRef>
-          <a:effectRef idx="2">
-            <a:schemeClr val="accent1"/>
-          </a:effectRef>
-          <a:fontRef idx="minor">
-            <a:schemeClr val="lt1"/>
-          </a:fontRef>
-        </p:style>
-        <p:txBody>
-          <a:bodyPr rtlCol="0" anchor="ctr"/>
-          <a:lstStyle/>
-          <a:p>
-            <a:pPr algn="ctr"/>
-            <a:endParaRPr/>
-          </a:p>
-        </p:txBody>
-      </p:sp>
-      <p:sp>
-        <p:nvSpPr>
-          <p:cNvPr id="5" name="Rounded Rectangle 4"/>
-          <p:cNvSpPr/>
-          <p:nvPr/>
-        </p:nvSpPr>
-        <p:spPr>
-          <a:xfrm>
-            <a:off x="731520" y="128016"/>
-            <a:ext cx="3657600" cy="237744"/>
-          </a:xfrm>
-          <a:prstGeom prst="roundRect">
-            <a:avLst/>
-          </a:prstGeom>
-          <a:solidFill>
-            <a:srgbClr val="EEF2FF"/>
-          </a:solidFill>
-          <a:ln w="9525">
-            <a:solidFill>
-              <a:srgbClr val="C7D2FE"/>
-            </a:solidFill>
-          </a:ln>
-        </p:spPr>
-        <p:style>
-          <a:lnRef idx="1">
-            <a:schemeClr val="accent1"/>
-          </a:lnRef>
-          <a:fillRef idx="3">
-            <a:schemeClr val="accent1"/>
-          </a:fillRef>
-          <a:effectRef idx="2">
-            <a:schemeClr val="accent1"/>
-          </a:effectRef>
-          <a:fontRef idx="minor">
-            <a:schemeClr val="lt1"/>
-          </a:fontRef>
-        </p:style>
-        <p:txBody>
-          <a:bodyPr wrap="none" lIns="73152" tIns="18288" rIns="73152" bIns="18288" rtlCol="0" anchor="ctr"/>
-          <a:lstStyle/>
-          <a:p>
-            <a:pPr algn="ctr">
-              <a:defRPr sz="850" b="1">
-                <a:solidFill>
-                  <a:srgbClr val="2563EB"/>
-                </a:solidFill>
-                <a:latin typeface="Segoe UI"/>
-              </a:defRPr>
-            </a:pPr>
-            <a:r>
-              <a:t>CHƯƠNG 2: LUỒNG QUẢN TRỊ HỆ THỐNG</a:t>
-            </a:r>
-          </a:p>
-        </p:txBody>
-      </p:sp>
-      <p:sp>
-        <p:nvSpPr>
-          <p:cNvPr id="6" name="TextBox 5"/>
-          <p:cNvSpPr txBox="1"/>
-          <p:nvPr/>
-        </p:nvSpPr>
-        <p:spPr>
-          <a:xfrm>
-            <a:off x="731520" y="402336"/>
-            <a:ext cx="10698480" cy="594360"/>
-          </a:xfrm>
-          <a:prstGeom prst="rect">
-            <a:avLst/>
-          </a:prstGeom>
-          <a:noFill/>
-        </p:spPr>
-        <p:txBody>
-          <a:bodyPr wrap="square" lIns="0" tIns="0">
-            <a:spAutoFit/>
-          </a:bodyPr>
-          <a:lstStyle/>
-          <a:p>
-            <a:pPr>
-              <a:defRPr sz="1900" b="1">
-                <a:solidFill>
-                  <a:srgbClr val="1E3A8A"/>
-                </a:solidFill>
-                <a:latin typeface="Segoe UI"/>
-              </a:defRPr>
-            </a:pPr>
-            <a:r>
-              <a:t>Luồng Quản Trị Hệ Thống: Cấu Hình, Kiểm Soát Kho &amp; Giám Sát KPI</a:t>
-            </a:r>
-          </a:p>
-          <a:p>
-            <a:pPr>
-              <a:defRPr sz="1050">
-                <a:solidFill>
-                  <a:srgbClr val="475569"/>
-                </a:solidFill>
-                <a:latin typeface="Segoe UI"/>
-              </a:defRPr>
-            </a:pPr>
-            <a:r>
-              <a:t>Chu trình 4 trụ cột vận hành: Phân quyền RBAC ➔ Thực đơn &amp; Định mức BOM ➔ Quản lý kho ➔ Phân tích Dashboard</a:t>
-            </a:r>
-          </a:p>
-        </p:txBody>
-      </p:sp>
-      <p:sp>
-        <p:nvSpPr>
-          <p:cNvPr id="7" name="TextBox 6"/>
-          <p:cNvSpPr txBox="1"/>
-          <p:nvPr/>
-        </p:nvSpPr>
-        <p:spPr>
-          <a:xfrm>
-            <a:off x="731520" y="6510528"/>
-            <a:ext cx="10728655" cy="292608"/>
-          </a:xfrm>
-          <a:prstGeom prst="rect">
-            <a:avLst/>
-          </a:prstGeom>
-          <a:noFill/>
-        </p:spPr>
-        <p:txBody>
-          <a:bodyPr wrap="none" lIns="0" tIns="0">
-            <a:spAutoFit/>
-          </a:bodyPr>
-          <a:lstStyle/>
-          <a:p>
-            <a:pPr>
-              <a:defRPr sz="900">
-                <a:solidFill>
-                  <a:srgbClr val="94A3B8"/>
-                </a:solidFill>
-                <a:latin typeface="Segoe UI"/>
-              </a:defRPr>
-            </a:pPr>
-            <a:r>
-              <a:t>Đồ Án Chuyên Đề Back-End: Royal Bistro | Sinh viên: Nguyễn Hoàng Hưng – 501250384 (K25)                                 Trang 8/13</a:t>
-            </a:r>
-          </a:p>
-        </p:txBody>
-      </p:sp>
-      <p:sp>
-        <p:nvSpPr>
-          <p:cNvPr id="8" name="Rounded Rectangle 7"/>
-          <p:cNvSpPr/>
-          <p:nvPr/>
-        </p:nvSpPr>
-        <p:spPr>
-          <a:xfrm>
-            <a:off x="731520" y="1234440"/>
-            <a:ext cx="5760720" cy="1170432"/>
-          </a:xfrm>
-          <a:prstGeom prst="roundRect">
-            <a:avLst/>
-          </a:prstGeom>
-          <a:solidFill>
-            <a:srgbClr val="FFFFFF"/>
-          </a:solidFill>
-          <a:ln w="19050">
-            <a:solidFill>
-              <a:srgbClr val="2563EB"/>
-            </a:solidFill>
-          </a:ln>
-        </p:spPr>
-        <p:style>
-          <a:lnRef idx="1">
-            <a:schemeClr val="accent1"/>
-          </a:lnRef>
-          <a:fillRef idx="3">
-            <a:schemeClr val="accent1"/>
-          </a:fillRef>
-          <a:effectRef idx="2">
-            <a:schemeClr val="accent1"/>
-          </a:effectRef>
-          <a:fontRef idx="minor">
-            <a:schemeClr val="lt1"/>
-          </a:fontRef>
-        </p:style>
-        <p:txBody>
-          <a:bodyPr wrap="square" lIns="164592" tIns="73152" rIns="164592" rtlCol="0" anchor="ctr"/>
-          <a:lstStyle/>
-          <a:p>
-            <a:pPr algn="ctr">
-              <a:defRPr sz="1050" b="1">
-                <a:solidFill>
-                  <a:srgbClr val="2563EB"/>
-                </a:solidFill>
-                <a:latin typeface="Segoe UI"/>
-              </a:defRPr>
-            </a:pPr>
-            <a:r>
-              <a:rPr sz="1200"/>
-              <a:t>🔐 TRỤ CỘT 1: ĐĂNG NHẬP BẢO MẬT &amp; PHÂN QUYỀN RBAC</a:t>
-            </a:r>
-          </a:p>
-          <a:p>
-            <a:pPr>
-              <a:spcBef>
-                <a:spcPts val="200"/>
-              </a:spcBef>
-              <a:defRPr sz="880" b="1">
-                <a:solidFill>
-                  <a:srgbClr val="0F172A"/>
-                </a:solidFill>
-                <a:latin typeface="Segoe UI"/>
-              </a:defRPr>
-            </a:pPr>
-            <a:r>
-              <a:rPr sz="1000"/>
-              <a:t>• Xác thực JWT an toàn: </a:t>
-            </a:r>
-            <a:r>
-              <a:rPr sz="1000" b="0">
-                <a:solidFill>
-                  <a:srgbClr val="475569"/>
-                </a:solidFill>
-              </a:rPr>
-              <a:t>Admin đăng nhập qua POST /api/v1/auth/login, kiểm tra Bcrypt 10 rounds, cấp JWT 24h.</a:t>
-            </a:r>
-          </a:p>
-          <a:p>
-            <a:pPr>
-              <a:spcBef>
-                <a:spcPts val="200"/>
-              </a:spcBef>
-              <a:defRPr sz="880" b="1">
-                <a:solidFill>
-                  <a:srgbClr val="0F172A"/>
-                </a:solidFill>
-                <a:latin typeface="Segoe UI"/>
-              </a:defRPr>
-            </a:pPr>
-            <a:r>
-              <a:rPr sz="1000"/>
-              <a:t>• Phân quyền đa tầng: </a:t>
-            </a:r>
-            <a:r>
-              <a:rPr sz="1000" b="0">
-                <a:solidFill>
-                  <a:srgbClr val="475569"/>
-                </a:solidFill>
-              </a:rPr>
-              <a:t>Quản lý tài khoản nhân sự; Middleware RBAC chặn nghiêm ngặt các vai trò Thu ngân và Bếp.</a:t>
-            </a:r>
-          </a:p>
-        </p:txBody>
-      </p:sp>
-      <p:sp>
-        <p:nvSpPr>
-          <p:cNvPr id="9" name="Rounded Rectangle 8"/>
-          <p:cNvSpPr/>
-          <p:nvPr/>
-        </p:nvSpPr>
-        <p:spPr>
-          <a:xfrm>
-            <a:off x="731520" y="2523744"/>
-            <a:ext cx="5760720" cy="1170432"/>
-          </a:xfrm>
-          <a:prstGeom prst="roundRect">
-            <a:avLst/>
-          </a:prstGeom>
-          <a:solidFill>
-            <a:srgbClr val="FFFFFF"/>
-          </a:solidFill>
-          <a:ln w="19050">
-            <a:solidFill>
-              <a:srgbClr val="D97706"/>
-            </a:solidFill>
-          </a:ln>
-        </p:spPr>
-        <p:style>
-          <a:lnRef idx="1">
-            <a:schemeClr val="accent1"/>
-          </a:lnRef>
-          <a:fillRef idx="3">
-            <a:schemeClr val="accent1"/>
-          </a:fillRef>
-          <a:effectRef idx="2">
-            <a:schemeClr val="accent1"/>
-          </a:effectRef>
-          <a:fontRef idx="minor">
-            <a:schemeClr val="lt1"/>
-          </a:fontRef>
-        </p:style>
-        <p:txBody>
-          <a:bodyPr wrap="square" lIns="164592" tIns="73152" rIns="164592" rtlCol="0" anchor="ctr"/>
-          <a:lstStyle/>
-          <a:p>
-            <a:pPr algn="ctr">
-              <a:defRPr sz="1050" b="1">
-                <a:solidFill>
-                  <a:srgbClr val="D97706"/>
-                </a:solidFill>
-                <a:latin typeface="Segoe UI"/>
-              </a:defRPr>
-            </a:pPr>
-            <a:r>
-              <a:rPr sz="1200"/>
-              <a:t>🍲 TRỤ CỘT 2: QUẢN TRỊ MENU &amp; THIẾT LẬP ĐỊNH MỨC BOM</a:t>
-            </a:r>
-          </a:p>
-          <a:p>
-            <a:pPr>
-              <a:spcBef>
-                <a:spcPts val="200"/>
-              </a:spcBef>
-              <a:defRPr sz="880" b="1">
-                <a:solidFill>
-                  <a:srgbClr val="0F172A"/>
-                </a:solidFill>
-                <a:latin typeface="Segoe UI"/>
-              </a:defRPr>
-            </a:pPr>
-            <a:r>
-              <a:rPr sz="1000"/>
-              <a:t>• Quản lý thực đơn: </a:t>
-            </a:r>
-            <a:r>
-              <a:rPr sz="1000" b="0">
-                <a:solidFill>
-                  <a:srgbClr val="475569"/>
-                </a:solidFill>
-              </a:rPr>
-              <a:t>CRUD danh mục, thêm món ăn, upload ảnh đại diện Cloudinary, quản lý trạng thái bật/tắt bán.</a:t>
-            </a:r>
-          </a:p>
-          <a:p>
-            <a:pPr>
-              <a:spcBef>
-                <a:spcPts val="200"/>
-              </a:spcBef>
-              <a:defRPr sz="880" b="1">
-                <a:solidFill>
-                  <a:srgbClr val="0F172A"/>
-                </a:solidFill>
-                <a:latin typeface="Segoe UI"/>
-              </a:defRPr>
-            </a:pPr>
-            <a:r>
-              <a:rPr sz="1000"/>
-              <a:t>• Cấu hình công thức BOM: </a:t>
-            </a:r>
-            <a:r>
-              <a:rPr sz="1000" b="0">
-                <a:solidFill>
-                  <a:srgbClr val="475569"/>
-                </a:solidFill>
-              </a:rPr>
-              <a:t>Thiết lập liên kết MonAnNguyenLieu (định lượng gram/ml tiêu hao chính xác cho mỗi món).</a:t>
-            </a:r>
-          </a:p>
-        </p:txBody>
-      </p:sp>
-      <p:sp>
-        <p:nvSpPr>
-          <p:cNvPr id="10" name="Rounded Rectangle 9"/>
-          <p:cNvSpPr/>
-          <p:nvPr/>
-        </p:nvSpPr>
-        <p:spPr>
-          <a:xfrm>
-            <a:off x="731520" y="3813048"/>
-            <a:ext cx="5760720" cy="1170432"/>
-          </a:xfrm>
-          <a:prstGeom prst="roundRect">
-            <a:avLst/>
-          </a:prstGeom>
-          <a:solidFill>
-            <a:srgbClr val="FFFFFF"/>
-          </a:solidFill>
-          <a:ln w="19050">
-            <a:solidFill>
-              <a:srgbClr val="DC2626"/>
-            </a:solidFill>
-          </a:ln>
-        </p:spPr>
-        <p:style>
-          <a:lnRef idx="1">
-            <a:schemeClr val="accent1"/>
-          </a:lnRef>
-          <a:fillRef idx="3">
-            <a:schemeClr val="accent1"/>
-          </a:fillRef>
-          <a:effectRef idx="2">
-            <a:schemeClr val="accent1"/>
-          </a:effectRef>
-          <a:fontRef idx="minor">
-            <a:schemeClr val="lt1"/>
-          </a:fontRef>
-        </p:style>
-        <p:txBody>
-          <a:bodyPr wrap="square" lIns="164592" tIns="73152" rIns="164592" rtlCol="0" anchor="ctr"/>
-          <a:lstStyle/>
-          <a:p>
-            <a:pPr algn="ctr">
-              <a:defRPr sz="1050" b="1">
-                <a:solidFill>
-                  <a:srgbClr val="DC2626"/>
-                </a:solidFill>
-                <a:latin typeface="Segoe UI"/>
-              </a:defRPr>
-            </a:pPr>
-            <a:r>
-              <a:rPr sz="1200"/>
-              <a:t>📦 TRỤ CỘT 3: KIỂM SOÁT KHO &amp; CẢNH BÁO TỒN TỐI THIỂU</a:t>
-            </a:r>
-          </a:p>
-          <a:p>
-            <a:pPr>
-              <a:spcBef>
-                <a:spcPts val="200"/>
-              </a:spcBef>
-              <a:defRPr sz="880" b="1">
-                <a:solidFill>
-                  <a:srgbClr val="0F172A"/>
-                </a:solidFill>
-                <a:latin typeface="Segoe UI"/>
-              </a:defRPr>
-            </a:pPr>
-            <a:r>
-              <a:rPr sz="1000"/>
-              <a:t>• Nhập kho nguyên liệu: </a:t>
-            </a:r>
-            <a:r>
-              <a:rPr sz="1000" b="0">
-                <a:solidFill>
-                  <a:srgbClr val="475569"/>
-                </a:solidFill>
-              </a:rPr>
-              <a:t>Quản lý chứng từ nhập kho, cập nhật đơn giá, nhà cung cấp và số lượng tồn hiện hành.</a:t>
-            </a:r>
-          </a:p>
-          <a:p>
-            <a:pPr>
-              <a:spcBef>
-                <a:spcPts val="200"/>
-              </a:spcBef>
-              <a:defRPr sz="880" b="1">
-                <a:solidFill>
-                  <a:srgbClr val="0F172A"/>
-                </a:solidFill>
-                <a:latin typeface="Segoe UI"/>
-              </a:defRPr>
-            </a:pPr>
-            <a:r>
-              <a:rPr sz="1000"/>
-              <a:t>• Tự động trừ kho &amp; Cảnh báo: </a:t>
-            </a:r>
-            <a:r>
-              <a:rPr sz="1000" b="0">
-                <a:solidFill>
-                  <a:srgbClr val="475569"/>
-                </a:solidFill>
-              </a:rPr>
-              <a:t>Bếp bấm nấu ➔ Back-End tự khấu trừ kho theo BOM; kích hoạt cảnh báo khi chạm ngưỡng tối thiểu.</a:t>
-            </a:r>
-          </a:p>
-        </p:txBody>
-      </p:sp>
-      <p:sp>
-        <p:nvSpPr>
-          <p:cNvPr id="11" name="Rounded Rectangle 10"/>
-          <p:cNvSpPr/>
-          <p:nvPr/>
-        </p:nvSpPr>
-        <p:spPr>
-          <a:xfrm>
-            <a:off x="731520" y="5102352"/>
-            <a:ext cx="5760720" cy="1170432"/>
-          </a:xfrm>
-          <a:prstGeom prst="roundRect">
-            <a:avLst/>
-          </a:prstGeom>
-          <a:solidFill>
-            <a:srgbClr val="FFFFFF"/>
-          </a:solidFill>
-          <a:ln w="19050">
-            <a:solidFill>
-              <a:srgbClr val="059669"/>
-            </a:solidFill>
-          </a:ln>
-        </p:spPr>
-        <p:style>
-          <a:lnRef idx="1">
-            <a:schemeClr val="accent1"/>
-          </a:lnRef>
-          <a:fillRef idx="3">
-            <a:schemeClr val="accent1"/>
-          </a:fillRef>
-          <a:effectRef idx="2">
-            <a:schemeClr val="accent1"/>
-          </a:effectRef>
-          <a:fontRef idx="minor">
-            <a:schemeClr val="lt1"/>
-          </a:fontRef>
-        </p:style>
-        <p:txBody>
-          <a:bodyPr wrap="square" lIns="164592" tIns="73152" rIns="164592" rtlCol="0" anchor="ctr"/>
-          <a:lstStyle/>
-          <a:p>
-            <a:pPr algn="ctr">
-              <a:defRPr sz="1050" b="1">
-                <a:solidFill>
-                  <a:srgbClr val="059669"/>
-                </a:solidFill>
-                <a:latin typeface="Segoe UI"/>
-              </a:defRPr>
-            </a:pPr>
-            <a:r>
-              <a:rPr sz="1200"/>
-              <a:t>📊 TRỤ CỘT 4: GIÁM SÁT DASHBOARD &amp; PHÂN TÍCH KPI TÀI CHÍNH</a:t>
-            </a:r>
-          </a:p>
-          <a:p>
-            <a:pPr>
-              <a:spcBef>
-                <a:spcPts val="200"/>
-              </a:spcBef>
-              <a:defRPr sz="880" b="1">
-                <a:solidFill>
-                  <a:srgbClr val="0F172A"/>
-                </a:solidFill>
-                <a:latin typeface="Segoe UI"/>
-              </a:defRPr>
-            </a:pPr>
-            <a:r>
-              <a:rPr sz="1000"/>
-              <a:t>• Dashboard thời gian thực: </a:t>
-            </a:r>
-            <a:r>
-              <a:rPr sz="1000" b="0">
-                <a:solidFill>
-                  <a:srgbClr val="475569"/>
-                </a:solidFill>
-              </a:rPr>
-              <a:t>Theo dõi tức thì doanh thu ca/ngày, tỷ lệ lấp đầy bàn ăn, số lượng đơn hoàn tất.</a:t>
-            </a:r>
-          </a:p>
-          <a:p>
-            <a:pPr>
-              <a:spcBef>
-                <a:spcPts val="200"/>
-              </a:spcBef>
-              <a:defRPr sz="880" b="1">
-                <a:solidFill>
-                  <a:srgbClr val="0F172A"/>
-                </a:solidFill>
-                <a:latin typeface="Segoe UI"/>
-              </a:defRPr>
-            </a:pPr>
-            <a:r>
-              <a:rPr sz="1000"/>
-              <a:t>• Báo cáo chuyên sâu: </a:t>
-            </a:r>
-            <a:r>
-              <a:rPr sz="1000" b="0">
-                <a:solidFill>
-                  <a:srgbClr val="475569"/>
-                </a:solidFill>
-              </a:rPr>
-              <a:t>Biểu đồ phân tích doanh thu theo kỳ, Top 5 món bán chạy nhất và tỷ suất hao hụt nguyên vật liệu.</a:t>
-            </a:r>
-          </a:p>
-        </p:txBody>
-      </p:sp>
-      <p:sp>
-        <p:nvSpPr>
-          <p:cNvPr id="12" name="Rounded Rectangle 11"/>
-          <p:cNvSpPr/>
-          <p:nvPr/>
-        </p:nvSpPr>
-        <p:spPr>
-          <a:xfrm>
-            <a:off x="6675120" y="1234440"/>
-            <a:ext cx="4785055" cy="5074920"/>
-          </a:xfrm>
-          <a:prstGeom prst="roundRect">
-            <a:avLst/>
-          </a:prstGeom>
-          <a:solidFill>
-            <a:schemeClr val="bg1">
-              <a:lumMod val="95000"/>
-            </a:schemeClr>
-          </a:solidFill>
-          <a:ln w="12700">
-            <a:solidFill>
-              <a:srgbClr val="E2E8F0"/>
-            </a:solidFill>
-          </a:ln>
-        </p:spPr>
-        <p:style>
-          <a:lnRef idx="1">
-            <a:schemeClr val="accent1"/>
-          </a:lnRef>
-          <a:fillRef idx="3">
-            <a:schemeClr val="accent1"/>
-          </a:fillRef>
-          <a:effectRef idx="2">
-            <a:schemeClr val="accent1"/>
-          </a:effectRef>
-          <a:fontRef idx="minor">
-            <a:schemeClr val="lt1"/>
-          </a:fontRef>
-        </p:style>
-        <p:txBody>
-          <a:bodyPr rtlCol="0" anchor="ctr"/>
-          <a:lstStyle/>
-          <a:p>
-            <a:pPr algn="ctr"/>
-            <a:endParaRPr/>
-          </a:p>
-        </p:txBody>
-      </p:sp>
-      <p:sp>
-        <p:nvSpPr>
-          <p:cNvPr id="13" name="TextBox 12"/>
-          <p:cNvSpPr txBox="1"/>
-          <p:nvPr/>
-        </p:nvSpPr>
-        <p:spPr>
-          <a:xfrm>
-            <a:off x="6812280" y="1935087"/>
-            <a:ext cx="4660250" cy="276999"/>
-          </a:xfrm>
-          <a:prstGeom prst="rect">
-            <a:avLst/>
-          </a:prstGeom>
-          <a:noFill/>
-        </p:spPr>
-        <p:txBody>
-          <a:bodyPr wrap="none">
-            <a:spAutoFit/>
-          </a:bodyPr>
-          <a:lstStyle/>
-          <a:p>
-            <a:pPr>
-              <a:defRPr sz="1000" b="1">
-                <a:solidFill>
-                  <a:srgbClr val="1E3A8A"/>
-                </a:solidFill>
-                <a:latin typeface="Segoe UI"/>
-              </a:defRPr>
-            </a:pPr>
-            <a:r>
-              <a:rPr sz="1200"/>
-              <a:t>📊 BẢNG ĐIỀU KHIỂN QUẢN TRỊ VIÊN (ADMIN DASHBOARD)</a:t>
-            </a:r>
-          </a:p>
-        </p:txBody>
-      </p:sp>
-      <p:pic>
-        <p:nvPicPr>
-          <p:cNvPr id="14" name="Picture 13" descr="02_dashboard.png"/>
-          <p:cNvPicPr>
-            <a:picLocks noChangeAspect="1"/>
-          </p:cNvPicPr>
-          <p:nvPr/>
-        </p:nvPicPr>
-        <p:blipFill>
-          <a:blip r:embed="rId2"/>
-          <a:stretch>
-            <a:fillRect/>
-          </a:stretch>
-        </p:blipFill>
-        <p:spPr>
-          <a:xfrm>
-            <a:off x="6812280" y="2486160"/>
-            <a:ext cx="4510735" cy="2929521"/>
-          </a:xfrm>
-          <a:prstGeom prst="rect">
-            <a:avLst/>
-          </a:prstGeom>
-        </p:spPr>
-      </p:pic>
-    </p:spTree>
-  </p:cSld>
-  <p:clrMapOvr>
-    <a:masterClrMapping/>
-  </p:clrMapOvr>
-</p:sld>
-</file>
-
-<file path=ppt/slides/slide7.xml><?xml version="1.0" encoding="utf-8"?>
 <p:sld xmlns:a="http://schemas.openxmlformats.org/drawingml/2006/main" xmlns:r="http://schemas.openxmlformats.org/officeDocument/2006/relationships" xmlns:p="http://schemas.openxmlformats.org/presentationml/2006/main">
   <p:cSld>
     <p:spTree>

</xml_diff>